<commit_message>
feat(ltp): expand process group coverage
AI 辅助说明：本次提交使用 AI 编程助手辅助进行代码检索、问题定位、补丁草拟、文档整理和回归验证命令组织。AI 输出仅作为工程辅助参考；关键设计取舍、实现合入、测试结果判断和最终提交由团队成员审阅确认。

本次提交涉及 LTP process-group 语义改进、默认 case 列表调整、验证记录整理以及汇报 PPT 更新，均经过人工检查，并使用实际构建和 focused LTP 日志进行验证。
</commit_message>
<xml_diff>
--- a/12345初赛汇报.pptx
+++ b/12345初赛汇报.pptx
@@ -30,6 +30,7 @@
     <p:sldId id="275" r:id="rId23"/>
     <p:sldId id="276" r:id="rId24"/>
     <p:sldId id="277" r:id="rId25"/>
+    <p:sldId id="278" r:id="rId26"/>
   </p:sldIdLst>
   <p:sldSz cx="12192000" cy="6858000"/>
   <p:notesSz cx="6858000" cy="9144000"/>
@@ -1168,6 +1169,70 @@
 </file>
 
 <file path=ppt/notesSlides/notesSlide22.xml><?xml version="1.0" encoding="utf-8"?>
+<p:notes xmlns:a="http://schemas.openxmlformats.org/drawingml/2006/main" xmlns:r="http://schemas.openxmlformats.org/officeDocument/2006/relationships" xmlns:p="http://schemas.openxmlformats.org/presentationml/2006/main">
+  <p:cSld>
+    <p:spTree>
+      <p:nvGrpSpPr>
+        <p:cNvPr id="1" name=""/>
+        <p:cNvGrpSpPr/>
+        <p:nvPr/>
+      </p:nvGrpSpPr>
+      <p:grpSpPr/>
+      <p:sp>
+        <p:nvSpPr>
+          <p:cNvPr id="2" name="Slide Image Placeholder 1"/>
+          <p:cNvSpPr>
+            <a:spLocks noGrp="1"/>
+          </p:cNvSpPr>
+          <p:nvPr>
+            <p:ph type="sldImg"/>
+          </p:nvPr>
+        </p:nvSpPr>
+        <p:spPr/>
+      </p:sp>
+      <p:sp>
+        <p:nvSpPr>
+          <p:cNvPr id="3" name="Notes Placeholder 2"/>
+          <p:cNvSpPr>
+            <a:spLocks noGrp="1"/>
+          </p:cNvSpPr>
+          <p:nvPr>
+            <p:ph type="body" idx="1"/>
+          </p:nvPr>
+        </p:nvSpPr>
+        <p:spPr/>
+        <p:txBody>
+          <a:bodyPr/>
+          <a:lstStyle/>
+          <a:p/>
+        </p:txBody>
+      </p:sp>
+      <p:sp>
+        <p:nvSpPr>
+          <p:cNvPr id="4" name="Slide Number Placeholder 3"/>
+          <p:cNvSpPr>
+            <a:spLocks noGrp="1"/>
+          </p:cNvSpPr>
+          <p:nvPr>
+            <p:ph type="sldNum" idx="5"/>
+          </p:nvPr>
+        </p:nvSpPr>
+        <p:spPr/>
+        <p:txBody>
+          <a:bodyPr/>
+          <a:lstStyle/>
+          <a:p/>
+        </p:txBody>
+      </p:sp>
+    </p:spTree>
+  </p:cSld>
+  <p:clrMapOvr>
+    <a:masterClrMapping/>
+  </p:clrMapOvr>
+</p:notes>
+</file>
+
+<file path=ppt/notesSlides/notesSlide23.xml><?xml version="1.0" encoding="utf-8"?>
 <p:notes xmlns:a="http://schemas.openxmlformats.org/drawingml/2006/main" xmlns:r="http://schemas.openxmlformats.org/officeDocument/2006/relationships" xmlns:p="http://schemas.openxmlformats.org/presentationml/2006/main">
   <p:cSld>
     <p:spTree>
@@ -16437,7 +16502,7 @@
                   <a:srgbClr val="111111"/>
                 </a:solidFill>
               </a:rPr>
-              <a:t>总结与计划</a:t>
+              <a:t>AI 使用说明</a:t>
             </a:r>
             <a:endParaRPr sz="2550" b="1">
               <a:solidFill>
@@ -16486,7 +16551,7 @@
                   <a:srgbClr val="4A4A4A"/>
                 </a:solidFill>
               </a:rPr>
-              <a:t>当前阶段成果与下一步重点</a:t>
+              <a:t>团队决策主导，AI 辅助实现与整理</a:t>
             </a:r>
             <a:endParaRPr sz="1050" b="1">
               <a:solidFill>
@@ -16582,12 +16647,12 @@
         </p:nvSpPr>
         <p:spPr>
           <a:xfrm>
-            <a:off x="819150" y="1428750"/>
-            <a:ext cx="3276600" cy="1809750"/>
+            <a:off x="876300" y="1466850"/>
+            <a:ext cx="4191000" cy="3028950"/>
           </a:xfrm>
           <a:prstGeom prst="roundRect">
             <a:avLst>
-              <a:gd name="adj" fmla="val 4211"/>
+              <a:gd name="adj" fmla="val 2516"/>
             </a:avLst>
           </a:prstGeom>
           <a:solidFill>
@@ -16611,35 +16676,82 @@
         </p:nvSpPr>
         <p:spPr>
           <a:xfrm>
-            <a:off x="819150" y="1428750"/>
-            <a:ext cx="47625" cy="1809750"/>
-          </a:xfrm>
-          <a:prstGeom prst="rect">
+            <a:off x="1219200" y="1790700"/>
+            <a:ext cx="1714500" cy="323850"/>
+          </a:xfrm>
+          <a:prstGeom prst="rect">
+            <a:avLst/>
+          </a:prstGeom>
+          <a:noFill/>
+          <a:ln w="0">
+            <a:noFill/>
+            <a:prstDash val="solid"/>
+          </a:ln>
+        </p:spPr>
+        <p:txBody>
+          <a:bodyPr lIns="0" tIns="0" rIns="0" bIns="0" anchor="t"/>
+          <a:lstStyle/>
+          <a:p>
+            <a:pPr algn="l">
+              <a:defRPr sz="1950" b="1">
+                <a:solidFill>
+                  <a:srgbClr val="111111"/>
+                </a:solidFill>
+              </a:defRPr>
+            </a:pPr>
+            <a:r>
+              <a:rPr sz="1950" b="1">
+                <a:solidFill>
+                  <a:srgbClr val="111111"/>
+                </a:solidFill>
+              </a:rPr>
+              <a:t>团队主导</a:t>
+            </a:r>
+            <a:endParaRPr sz="1950" b="1">
+              <a:solidFill>
+                <a:srgbClr val="111111"/>
+              </a:solidFill>
+            </a:endParaRPr>
+          </a:p>
+        </p:txBody>
+      </p:sp>
+      <p:sp>
+        <p:nvSpPr>
+          <p:cNvPr id="8" name="椭圆 7"/>
+          <p:cNvSpPr>
+            <a:spLocks noGrp="1"/>
+          </p:cNvSpPr>
+          <p:nvPr/>
+        </p:nvSpPr>
+        <p:spPr>
+          <a:xfrm>
+            <a:off x="1257300" y="2495550"/>
+            <a:ext cx="66675" cy="66675"/>
+          </a:xfrm>
+          <a:prstGeom prst="ellipse">
             <a:avLst/>
           </a:prstGeom>
           <a:solidFill>
-            <a:srgbClr val="111111"/>
+            <a:srgbClr val="172033"/>
           </a:solidFill>
-          <a:ln w="9525">
-            <a:solidFill>
-              <a:srgbClr val="111111"/>
-            </a:solidFill>
-            <a:prstDash val="solid"/>
-          </a:ln>
-        </p:spPr>
-      </p:sp>
-      <p:sp>
-        <p:nvSpPr>
-          <p:cNvPr id="8" name="矩形 7"/>
-          <p:cNvSpPr>
-            <a:spLocks noGrp="1"/>
-          </p:cNvSpPr>
-          <p:nvPr/>
-        </p:nvSpPr>
-        <p:spPr>
-          <a:xfrm>
-            <a:off x="1028700" y="1600200"/>
-            <a:ext cx="2952750" cy="266700"/>
+          <a:ln w="0">
+            <a:noFill/>
+            <a:prstDash val="solid"/>
+          </a:ln>
+        </p:spPr>
+      </p:sp>
+      <p:sp>
+        <p:nvSpPr>
+          <p:cNvPr id="9" name="矩形 8"/>
+          <p:cNvSpPr>
+            <a:spLocks noGrp="1"/>
+          </p:cNvSpPr>
+          <p:nvPr/>
+        </p:nvSpPr>
+        <p:spPr>
+          <a:xfrm>
+            <a:off x="1447800" y="2419350"/>
+            <a:ext cx="3143250" cy="400050"/>
           </a:xfrm>
           <a:prstGeom prst="rect">
             <a:avLst/>
@@ -16655,40 +16767,65 @@
           <a:lstStyle/>
           <a:p>
             <a:pPr algn="l">
-              <a:defRPr sz="1500" b="1">
-                <a:solidFill>
-                  <a:srgbClr val="111111"/>
-                </a:solidFill>
-              </a:defRPr>
-            </a:pPr>
-            <a:r>
-              <a:rPr sz="1500" b="1">
-                <a:solidFill>
-                  <a:srgbClr val="111111"/>
-                </a:solidFill>
-              </a:rPr>
-              <a:t>阶段成果</a:t>
-            </a:r>
-            <a:endParaRPr sz="1500" b="1">
-              <a:solidFill>
-                <a:srgbClr val="111111"/>
-              </a:solidFill>
-            </a:endParaRPr>
-          </a:p>
-        </p:txBody>
-      </p:sp>
-      <p:sp>
-        <p:nvSpPr>
-          <p:cNvPr id="9" name="矩形 8"/>
-          <p:cNvSpPr>
-            <a:spLocks noGrp="1"/>
-          </p:cNvSpPr>
-          <p:nvPr/>
-        </p:nvSpPr>
-        <p:spPr>
-          <a:xfrm>
-            <a:off x="1028700" y="1981200"/>
-            <a:ext cx="2933700" cy="1123950"/>
+              <a:defRPr sz="1350" b="0">
+                <a:solidFill>
+                  <a:srgbClr val="172033"/>
+                </a:solidFill>
+              </a:defRPr>
+            </a:pPr>
+            <a:r>
+              <a:rPr sz="1350" b="0">
+                <a:solidFill>
+                  <a:srgbClr val="172033"/>
+                </a:solidFill>
+              </a:rPr>
+              <a:t>确定系统架构与模块边界</a:t>
+            </a:r>
+            <a:endParaRPr sz="1350" b="0">
+              <a:solidFill>
+                <a:srgbClr val="172033"/>
+              </a:solidFill>
+            </a:endParaRPr>
+          </a:p>
+        </p:txBody>
+      </p:sp>
+      <p:sp>
+        <p:nvSpPr>
+          <p:cNvPr id="10" name="椭圆 9"/>
+          <p:cNvSpPr>
+            <a:spLocks noGrp="1"/>
+          </p:cNvSpPr>
+          <p:nvPr/>
+        </p:nvSpPr>
+        <p:spPr>
+          <a:xfrm>
+            <a:off x="1257300" y="2952750"/>
+            <a:ext cx="66675" cy="66675"/>
+          </a:xfrm>
+          <a:prstGeom prst="ellipse">
+            <a:avLst/>
+          </a:prstGeom>
+          <a:solidFill>
+            <a:srgbClr val="172033"/>
+          </a:solidFill>
+          <a:ln w="0">
+            <a:noFill/>
+            <a:prstDash val="solid"/>
+          </a:ln>
+        </p:spPr>
+      </p:sp>
+      <p:sp>
+        <p:nvSpPr>
+          <p:cNvPr id="11" name="矩形 10"/>
+          <p:cNvSpPr>
+            <a:spLocks noGrp="1"/>
+          </p:cNvSpPr>
+          <p:nvPr/>
+        </p:nvSpPr>
+        <p:spPr>
+          <a:xfrm>
+            <a:off x="1447800" y="2876550"/>
+            <a:ext cx="3143250" cy="400050"/>
           </a:xfrm>
           <a:prstGeom prst="rect">
             <a:avLst/>
@@ -16704,44 +16841,192 @@
           <a:lstStyle/>
           <a:p>
             <a:pPr algn="l">
-              <a:defRPr sz="1125" b="0">
-                <a:solidFill>
-                  <a:srgbClr val="4A4A4A"/>
-                </a:solidFill>
-              </a:defRPr>
-            </a:pPr>
-            <a:r>
-              <a:rPr sz="1125" b="0">
-                <a:solidFill>
-                  <a:srgbClr val="4A4A4A"/>
-                </a:solidFill>
-              </a:rPr>
-              <a:t>完成双架构构建、运行时 ext4 脚本发现、核心 syscall 分层、VFS/FD、mmap/shm/futex/signal/socket 子集，以及多 suite harness 闭环。</a:t>
-            </a:r>
-            <a:endParaRPr sz="1125" b="0">
-              <a:solidFill>
-                <a:srgbClr val="4A4A4A"/>
-              </a:solidFill>
-            </a:endParaRPr>
-          </a:p>
-        </p:txBody>
-      </p:sp>
-      <p:sp>
-        <p:nvSpPr>
-          <p:cNvPr id="10" name="圆角矩形 9"/>
-          <p:cNvSpPr>
-            <a:spLocks noGrp="1"/>
-          </p:cNvSpPr>
-          <p:nvPr/>
-        </p:nvSpPr>
-        <p:spPr>
-          <a:xfrm>
-            <a:off x="4457700" y="1428750"/>
-            <a:ext cx="3276600" cy="1809750"/>
+              <a:defRPr sz="1350" b="0">
+                <a:solidFill>
+                  <a:srgbClr val="172033"/>
+                </a:solidFill>
+              </a:defRPr>
+            </a:pPr>
+            <a:r>
+              <a:rPr sz="1350" b="0">
+                <a:solidFill>
+                  <a:srgbClr val="172033"/>
+                </a:solidFill>
+              </a:rPr>
+              <a:t>选择 syscall 语义实现顺序</a:t>
+            </a:r>
+            <a:endParaRPr sz="1350" b="0">
+              <a:solidFill>
+                <a:srgbClr val="172033"/>
+              </a:solidFill>
+            </a:endParaRPr>
+          </a:p>
+        </p:txBody>
+      </p:sp>
+      <p:sp>
+        <p:nvSpPr>
+          <p:cNvPr id="12" name="椭圆 11"/>
+          <p:cNvSpPr>
+            <a:spLocks noGrp="1"/>
+          </p:cNvSpPr>
+          <p:nvPr/>
+        </p:nvSpPr>
+        <p:spPr>
+          <a:xfrm>
+            <a:off x="1257300" y="3409950"/>
+            <a:ext cx="66675" cy="66675"/>
+          </a:xfrm>
+          <a:prstGeom prst="ellipse">
+            <a:avLst/>
+          </a:prstGeom>
+          <a:solidFill>
+            <a:srgbClr val="172033"/>
+          </a:solidFill>
+          <a:ln w="0">
+            <a:noFill/>
+            <a:prstDash val="solid"/>
+          </a:ln>
+        </p:spPr>
+      </p:sp>
+      <p:sp>
+        <p:nvSpPr>
+          <p:cNvPr id="13" name="矩形 12"/>
+          <p:cNvSpPr>
+            <a:spLocks noGrp="1"/>
+          </p:cNvSpPr>
+          <p:nvPr/>
+        </p:nvSpPr>
+        <p:spPr>
+          <a:xfrm>
+            <a:off x="1447800" y="3333750"/>
+            <a:ext cx="3143250" cy="400050"/>
+          </a:xfrm>
+          <a:prstGeom prst="rect">
+            <a:avLst/>
+          </a:prstGeom>
+          <a:noFill/>
+          <a:ln w="0">
+            <a:noFill/>
+            <a:prstDash val="solid"/>
+          </a:ln>
+        </p:spPr>
+        <p:txBody>
+          <a:bodyPr lIns="0" tIns="0" rIns="0" bIns="0" anchor="t"/>
+          <a:lstStyle/>
+          <a:p>
+            <a:pPr algn="l">
+              <a:defRPr sz="1350" b="0">
+                <a:solidFill>
+                  <a:srgbClr val="172033"/>
+                </a:solidFill>
+              </a:defRPr>
+            </a:pPr>
+            <a:r>
+              <a:rPr sz="1350" b="0">
+                <a:solidFill>
+                  <a:srgbClr val="172033"/>
+                </a:solidFill>
+              </a:rPr>
+              <a:t>阅读评测日志并判断问题根因</a:t>
+            </a:r>
+            <a:endParaRPr sz="1350" b="0">
+              <a:solidFill>
+                <a:srgbClr val="172033"/>
+              </a:solidFill>
+            </a:endParaRPr>
+          </a:p>
+        </p:txBody>
+      </p:sp>
+      <p:sp>
+        <p:nvSpPr>
+          <p:cNvPr id="14" name="椭圆 13"/>
+          <p:cNvSpPr>
+            <a:spLocks noGrp="1"/>
+          </p:cNvSpPr>
+          <p:nvPr/>
+        </p:nvSpPr>
+        <p:spPr>
+          <a:xfrm>
+            <a:off x="1257300" y="3867150"/>
+            <a:ext cx="66675" cy="66675"/>
+          </a:xfrm>
+          <a:prstGeom prst="ellipse">
+            <a:avLst/>
+          </a:prstGeom>
+          <a:solidFill>
+            <a:srgbClr val="172033"/>
+          </a:solidFill>
+          <a:ln w="0">
+            <a:noFill/>
+            <a:prstDash val="solid"/>
+          </a:ln>
+        </p:spPr>
+      </p:sp>
+      <p:sp>
+        <p:nvSpPr>
+          <p:cNvPr id="15" name="矩形 14"/>
+          <p:cNvSpPr>
+            <a:spLocks noGrp="1"/>
+          </p:cNvSpPr>
+          <p:nvPr/>
+        </p:nvSpPr>
+        <p:spPr>
+          <a:xfrm>
+            <a:off x="1447800" y="3790950"/>
+            <a:ext cx="3143250" cy="400050"/>
+          </a:xfrm>
+          <a:prstGeom prst="rect">
+            <a:avLst/>
+          </a:prstGeom>
+          <a:noFill/>
+          <a:ln w="0">
+            <a:noFill/>
+            <a:prstDash val="solid"/>
+          </a:ln>
+        </p:spPr>
+        <p:txBody>
+          <a:bodyPr lIns="0" tIns="0" rIns="0" bIns="0" anchor="t"/>
+          <a:lstStyle/>
+          <a:p>
+            <a:pPr algn="l">
+              <a:defRPr sz="1350" b="0">
+                <a:solidFill>
+                  <a:srgbClr val="172033"/>
+                </a:solidFill>
+              </a:defRPr>
+            </a:pPr>
+            <a:r>
+              <a:rPr sz="1350" b="0">
+                <a:solidFill>
+                  <a:srgbClr val="172033"/>
+                </a:solidFill>
+              </a:rPr>
+              <a:t>决定取舍、合并与最终验证</a:t>
+            </a:r>
+            <a:endParaRPr sz="1350" b="0">
+              <a:solidFill>
+                <a:srgbClr val="172033"/>
+              </a:solidFill>
+            </a:endParaRPr>
+          </a:p>
+        </p:txBody>
+      </p:sp>
+      <p:sp>
+        <p:nvSpPr>
+          <p:cNvPr id="16" name="圆角矩形 15"/>
+          <p:cNvSpPr>
+            <a:spLocks noGrp="1"/>
+          </p:cNvSpPr>
+          <p:nvPr/>
+        </p:nvSpPr>
+        <p:spPr>
+          <a:xfrm>
+            <a:off x="6553200" y="1466850"/>
+            <a:ext cx="4191000" cy="3028950"/>
           </a:xfrm>
           <a:prstGeom prst="roundRect">
             <a:avLst>
-              <a:gd name="adj" fmla="val 4211"/>
+              <a:gd name="adj" fmla="val 2516"/>
             </a:avLst>
           </a:prstGeom>
           <a:solidFill>
@@ -16757,43 +17042,90 @@
       </p:sp>
       <p:sp>
         <p:nvSpPr>
-          <p:cNvPr id="11" name="矩形 10"/>
-          <p:cNvSpPr>
-            <a:spLocks noGrp="1"/>
-          </p:cNvSpPr>
-          <p:nvPr/>
-        </p:nvSpPr>
-        <p:spPr>
-          <a:xfrm>
-            <a:off x="4457700" y="1428750"/>
-            <a:ext cx="47625" cy="1809750"/>
-          </a:xfrm>
-          <a:prstGeom prst="rect">
+          <p:cNvPr id="17" name="矩形 16"/>
+          <p:cNvSpPr>
+            <a:spLocks noGrp="1"/>
+          </p:cNvSpPr>
+          <p:nvPr/>
+        </p:nvSpPr>
+        <p:spPr>
+          <a:xfrm>
+            <a:off x="6896100" y="1790700"/>
+            <a:ext cx="1714500" cy="323850"/>
+          </a:xfrm>
+          <a:prstGeom prst="rect">
+            <a:avLst/>
+          </a:prstGeom>
+          <a:noFill/>
+          <a:ln w="0">
+            <a:noFill/>
+            <a:prstDash val="solid"/>
+          </a:ln>
+        </p:spPr>
+        <p:txBody>
+          <a:bodyPr lIns="0" tIns="0" rIns="0" bIns="0" anchor="t"/>
+          <a:lstStyle/>
+          <a:p>
+            <a:pPr algn="l">
+              <a:defRPr sz="1950" b="1">
+                <a:solidFill>
+                  <a:srgbClr val="111111"/>
+                </a:solidFill>
+              </a:defRPr>
+            </a:pPr>
+            <a:r>
+              <a:rPr sz="1950" b="1">
+                <a:solidFill>
+                  <a:srgbClr val="111111"/>
+                </a:solidFill>
+              </a:rPr>
+              <a:t>AI 辅助</a:t>
+            </a:r>
+            <a:endParaRPr sz="1950" b="1">
+              <a:solidFill>
+                <a:srgbClr val="111111"/>
+              </a:solidFill>
+            </a:endParaRPr>
+          </a:p>
+        </p:txBody>
+      </p:sp>
+      <p:sp>
+        <p:nvSpPr>
+          <p:cNvPr id="18" name="椭圆 17"/>
+          <p:cNvSpPr>
+            <a:spLocks noGrp="1"/>
+          </p:cNvSpPr>
+          <p:nvPr/>
+        </p:nvSpPr>
+        <p:spPr>
+          <a:xfrm>
+            <a:off x="6934200" y="2495550"/>
+            <a:ext cx="66675" cy="66675"/>
+          </a:xfrm>
+          <a:prstGeom prst="ellipse">
             <a:avLst/>
           </a:prstGeom>
           <a:solidFill>
-            <a:srgbClr val="111111"/>
+            <a:srgbClr val="172033"/>
           </a:solidFill>
-          <a:ln w="9525">
-            <a:solidFill>
-              <a:srgbClr val="111111"/>
-            </a:solidFill>
-            <a:prstDash val="solid"/>
-          </a:ln>
-        </p:spPr>
-      </p:sp>
-      <p:sp>
-        <p:nvSpPr>
-          <p:cNvPr id="12" name="矩形 11"/>
-          <p:cNvSpPr>
-            <a:spLocks noGrp="1"/>
-          </p:cNvSpPr>
-          <p:nvPr/>
-        </p:nvSpPr>
-        <p:spPr>
-          <a:xfrm>
-            <a:off x="4667250" y="1600200"/>
-            <a:ext cx="2952750" cy="266700"/>
+          <a:ln w="0">
+            <a:noFill/>
+            <a:prstDash val="solid"/>
+          </a:ln>
+        </p:spPr>
+      </p:sp>
+      <p:sp>
+        <p:nvSpPr>
+          <p:cNvPr id="19" name="矩形 18"/>
+          <p:cNvSpPr>
+            <a:spLocks noGrp="1"/>
+          </p:cNvSpPr>
+          <p:nvPr/>
+        </p:nvSpPr>
+        <p:spPr>
+          <a:xfrm>
+            <a:off x="7124700" y="2419350"/>
+            <a:ext cx="3143250" cy="400050"/>
           </a:xfrm>
           <a:prstGeom prst="rect">
             <a:avLst/>
@@ -16809,40 +17141,65 @@
           <a:lstStyle/>
           <a:p>
             <a:pPr algn="l">
-              <a:defRPr sz="1500" b="1">
-                <a:solidFill>
-                  <a:srgbClr val="111111"/>
-                </a:solidFill>
-              </a:defRPr>
-            </a:pPr>
-            <a:r>
-              <a:rPr sz="1500" b="1">
-                <a:solidFill>
-                  <a:srgbClr val="111111"/>
-                </a:solidFill>
-              </a:rPr>
-              <a:t>技术特点</a:t>
-            </a:r>
-            <a:endParaRPr sz="1500" b="1">
-              <a:solidFill>
-                <a:srgbClr val="111111"/>
-              </a:solidFill>
-            </a:endParaRPr>
-          </a:p>
-        </p:txBody>
-      </p:sp>
-      <p:sp>
-        <p:nvSpPr>
-          <p:cNvPr id="13" name="矩形 12"/>
-          <p:cNvSpPr>
-            <a:spLocks noGrp="1"/>
-          </p:cNvSpPr>
-          <p:nvPr/>
-        </p:nvSpPr>
-        <p:spPr>
-          <a:xfrm>
-            <a:off x="4667250" y="1981200"/>
-            <a:ext cx="2933700" cy="1123950"/>
+              <a:defRPr sz="1350" b="0">
+                <a:solidFill>
+                  <a:srgbClr val="172033"/>
+                </a:solidFill>
+              </a:defRPr>
+            </a:pPr>
+            <a:r>
+              <a:rPr sz="1350" b="0">
+                <a:solidFill>
+                  <a:srgbClr val="172033"/>
+                </a:solidFill>
+              </a:rPr>
+              <a:t>生成局部代码草稿和测试思路</a:t>
+            </a:r>
+            <a:endParaRPr sz="1350" b="0">
+              <a:solidFill>
+                <a:srgbClr val="172033"/>
+              </a:solidFill>
+            </a:endParaRPr>
+          </a:p>
+        </p:txBody>
+      </p:sp>
+      <p:sp>
+        <p:nvSpPr>
+          <p:cNvPr id="20" name="椭圆 19"/>
+          <p:cNvSpPr>
+            <a:spLocks noGrp="1"/>
+          </p:cNvSpPr>
+          <p:nvPr/>
+        </p:nvSpPr>
+        <p:spPr>
+          <a:xfrm>
+            <a:off x="6934200" y="2952750"/>
+            <a:ext cx="66675" cy="66675"/>
+          </a:xfrm>
+          <a:prstGeom prst="ellipse">
+            <a:avLst/>
+          </a:prstGeom>
+          <a:solidFill>
+            <a:srgbClr val="172033"/>
+          </a:solidFill>
+          <a:ln w="0">
+            <a:noFill/>
+            <a:prstDash val="solid"/>
+          </a:ln>
+        </p:spPr>
+      </p:sp>
+      <p:sp>
+        <p:nvSpPr>
+          <p:cNvPr id="21" name="矩形 20"/>
+          <p:cNvSpPr>
+            <a:spLocks noGrp="1"/>
+          </p:cNvSpPr>
+          <p:nvPr/>
+        </p:nvSpPr>
+        <p:spPr>
+          <a:xfrm>
+            <a:off x="7124700" y="2876550"/>
+            <a:ext cx="3143250" cy="400050"/>
           </a:xfrm>
           <a:prstGeom prst="rect">
             <a:avLst/>
@@ -16858,48 +17215,245 @@
           <a:lstStyle/>
           <a:p>
             <a:pPr algn="l">
-              <a:defRPr sz="1125" b="0">
-                <a:solidFill>
-                  <a:srgbClr val="4A4A4A"/>
-                </a:solidFill>
-              </a:defRPr>
-            </a:pPr>
-            <a:r>
-              <a:rPr sz="1125" b="0">
-                <a:solidFill>
-                  <a:srgbClr val="4A4A4A"/>
-                </a:solidFill>
-              </a:rPr>
-              <a:t>Rust 内核、分层 ABI、真实等待队列、渐进式 LTP、以日志与 parser 为准的验证方式，便于持续定位评测差距。</a:t>
-            </a:r>
-            <a:endParaRPr sz="1125" b="0">
-              <a:solidFill>
-                <a:srgbClr val="4A4A4A"/>
-              </a:solidFill>
-            </a:endParaRPr>
-          </a:p>
-        </p:txBody>
-      </p:sp>
-      <p:sp>
-        <p:nvSpPr>
-          <p:cNvPr id="14" name="圆角矩形 13"/>
-          <p:cNvSpPr>
-            <a:spLocks noGrp="1"/>
-          </p:cNvSpPr>
-          <p:nvPr/>
-        </p:nvSpPr>
-        <p:spPr>
-          <a:xfrm>
-            <a:off x="8096250" y="1428750"/>
-            <a:ext cx="3276600" cy="1809750"/>
+              <a:defRPr sz="1350" b="0">
+                <a:solidFill>
+                  <a:srgbClr val="172033"/>
+                </a:solidFill>
+              </a:defRPr>
+            </a:pPr>
+            <a:r>
+              <a:rPr sz="1350" b="0">
+                <a:solidFill>
+                  <a:srgbClr val="172033"/>
+                </a:solidFill>
+              </a:rPr>
+              <a:t>辅助排查编译错误与运行日志</a:t>
+            </a:r>
+            <a:endParaRPr sz="1350" b="0">
+              <a:solidFill>
+                <a:srgbClr val="172033"/>
+              </a:solidFill>
+            </a:endParaRPr>
+          </a:p>
+        </p:txBody>
+      </p:sp>
+      <p:sp>
+        <p:nvSpPr>
+          <p:cNvPr id="22" name="椭圆 21"/>
+          <p:cNvSpPr>
+            <a:spLocks noGrp="1"/>
+          </p:cNvSpPr>
+          <p:nvPr/>
+        </p:nvSpPr>
+        <p:spPr>
+          <a:xfrm>
+            <a:off x="6934200" y="3409950"/>
+            <a:ext cx="66675" cy="66675"/>
+          </a:xfrm>
+          <a:prstGeom prst="ellipse">
+            <a:avLst/>
+          </a:prstGeom>
+          <a:solidFill>
+            <a:srgbClr val="172033"/>
+          </a:solidFill>
+          <a:ln w="0">
+            <a:noFill/>
+            <a:prstDash val="solid"/>
+          </a:ln>
+        </p:spPr>
+      </p:sp>
+      <p:sp>
+        <p:nvSpPr>
+          <p:cNvPr id="23" name="矩形 22"/>
+          <p:cNvSpPr>
+            <a:spLocks noGrp="1"/>
+          </p:cNvSpPr>
+          <p:nvPr/>
+        </p:nvSpPr>
+        <p:spPr>
+          <a:xfrm>
+            <a:off x="7124700" y="3333750"/>
+            <a:ext cx="3143250" cy="400050"/>
+          </a:xfrm>
+          <a:prstGeom prst="rect">
+            <a:avLst/>
+          </a:prstGeom>
+          <a:noFill/>
+          <a:ln w="0">
+            <a:noFill/>
+            <a:prstDash val="solid"/>
+          </a:ln>
+        </p:spPr>
+        <p:txBody>
+          <a:bodyPr lIns="0" tIns="0" rIns="0" bIns="0" anchor="t"/>
+          <a:lstStyle/>
+          <a:p>
+            <a:pPr algn="l">
+              <a:defRPr sz="1350" b="0">
+                <a:solidFill>
+                  <a:srgbClr val="172033"/>
+                </a:solidFill>
+              </a:defRPr>
+            </a:pPr>
+            <a:r>
+              <a:rPr sz="1350" b="0">
+                <a:solidFill>
+                  <a:srgbClr val="172033"/>
+                </a:solidFill>
+              </a:rPr>
+              <a:t>整理模块文档和汇报材料</a:t>
+            </a:r>
+            <a:endParaRPr sz="1350" b="0">
+              <a:solidFill>
+                <a:srgbClr val="172033"/>
+              </a:solidFill>
+            </a:endParaRPr>
+          </a:p>
+        </p:txBody>
+      </p:sp>
+      <p:sp>
+        <p:nvSpPr>
+          <p:cNvPr id="24" name="椭圆 23"/>
+          <p:cNvSpPr>
+            <a:spLocks noGrp="1"/>
+          </p:cNvSpPr>
+          <p:nvPr/>
+        </p:nvSpPr>
+        <p:spPr>
+          <a:xfrm>
+            <a:off x="6934200" y="3867150"/>
+            <a:ext cx="66675" cy="66675"/>
+          </a:xfrm>
+          <a:prstGeom prst="ellipse">
+            <a:avLst/>
+          </a:prstGeom>
+          <a:solidFill>
+            <a:srgbClr val="172033"/>
+          </a:solidFill>
+          <a:ln w="0">
+            <a:noFill/>
+            <a:prstDash val="solid"/>
+          </a:ln>
+        </p:spPr>
+      </p:sp>
+      <p:sp>
+        <p:nvSpPr>
+          <p:cNvPr id="25" name="矩形 24"/>
+          <p:cNvSpPr>
+            <a:spLocks noGrp="1"/>
+          </p:cNvSpPr>
+          <p:nvPr/>
+        </p:nvSpPr>
+        <p:spPr>
+          <a:xfrm>
+            <a:off x="7124700" y="3790950"/>
+            <a:ext cx="3143250" cy="400050"/>
+          </a:xfrm>
+          <a:prstGeom prst="rect">
+            <a:avLst/>
+          </a:prstGeom>
+          <a:noFill/>
+          <a:ln w="0">
+            <a:noFill/>
+            <a:prstDash val="solid"/>
+          </a:ln>
+        </p:spPr>
+        <p:txBody>
+          <a:bodyPr lIns="0" tIns="0" rIns="0" bIns="0" anchor="t"/>
+          <a:lstStyle/>
+          <a:p>
+            <a:pPr algn="l">
+              <a:defRPr sz="1350" b="0">
+                <a:solidFill>
+                  <a:srgbClr val="172033"/>
+                </a:solidFill>
+              </a:defRPr>
+            </a:pPr>
+            <a:r>
+              <a:rPr sz="1350" b="0">
+                <a:solidFill>
+                  <a:srgbClr val="172033"/>
+                </a:solidFill>
+              </a:rPr>
+              <a:t>提供备选实现方案供人工筛选</a:t>
+            </a:r>
+            <a:endParaRPr sz="1350" b="0">
+              <a:solidFill>
+                <a:srgbClr val="172033"/>
+              </a:solidFill>
+            </a:endParaRPr>
+          </a:p>
+        </p:txBody>
+      </p:sp>
+      <p:sp>
+        <p:nvSpPr>
+          <p:cNvPr id="26" name="矩形 25"/>
+          <p:cNvSpPr>
+            <a:spLocks noGrp="1"/>
+          </p:cNvSpPr>
+          <p:nvPr/>
+        </p:nvSpPr>
+        <p:spPr>
+          <a:xfrm>
+            <a:off x="5276850" y="2724150"/>
+            <a:ext cx="819150" cy="514350"/>
+          </a:xfrm>
+          <a:prstGeom prst="rect">
+            <a:avLst/>
+          </a:prstGeom>
+          <a:noFill/>
+          <a:ln w="0">
+            <a:noFill/>
+            <a:prstDash val="solid"/>
+          </a:ln>
+        </p:spPr>
+        <p:txBody>
+          <a:bodyPr lIns="0" tIns="0" rIns="0" bIns="0" anchor="t"/>
+          <a:lstStyle/>
+          <a:p>
+            <a:pPr algn="ctr">
+              <a:defRPr sz="3150" b="1">
+                <a:solidFill>
+                  <a:srgbClr val="172033"/>
+                </a:solidFill>
+              </a:defRPr>
+            </a:pPr>
+            <a:r>
+              <a:rPr sz="3150" b="1">
+                <a:solidFill>
+                  <a:srgbClr val="172033"/>
+                </a:solidFill>
+              </a:rPr>
+              <a:t>→</a:t>
+            </a:r>
+            <a:endParaRPr sz="3150" b="1">
+              <a:solidFill>
+                <a:srgbClr val="172033"/>
+              </a:solidFill>
+            </a:endParaRPr>
+          </a:p>
+        </p:txBody>
+      </p:sp>
+      <p:sp>
+        <p:nvSpPr>
+          <p:cNvPr id="27" name="圆角矩形 26"/>
+          <p:cNvSpPr>
+            <a:spLocks noGrp="1"/>
+          </p:cNvSpPr>
+          <p:nvPr/>
+        </p:nvSpPr>
+        <p:spPr>
+          <a:xfrm>
+            <a:off x="1676400" y="5067300"/>
+            <a:ext cx="8267700" cy="666750"/>
           </a:xfrm>
           <a:prstGeom prst="roundRect">
             <a:avLst>
-              <a:gd name="adj" fmla="val 4211"/>
+              <a:gd name="adj" fmla="val 11429"/>
             </a:avLst>
           </a:prstGeom>
           <a:solidFill>
-            <a:srgbClr val="FFFFFF"/>
+            <a:srgbClr val="F7F7F7"/>
           </a:solidFill>
           <a:ln w="9525">
             <a:solidFill>
@@ -16911,107 +17465,80 @@
       </p:sp>
       <p:sp>
         <p:nvSpPr>
-          <p:cNvPr id="15" name="矩形 14"/>
-          <p:cNvSpPr>
-            <a:spLocks noGrp="1"/>
-          </p:cNvSpPr>
-          <p:nvPr/>
-        </p:nvSpPr>
-        <p:spPr>
-          <a:xfrm>
-            <a:off x="8096250" y="1428750"/>
-            <a:ext cx="47625" cy="1809750"/>
-          </a:xfrm>
-          <a:prstGeom prst="rect">
-            <a:avLst/>
-          </a:prstGeom>
-          <a:solidFill>
-            <a:srgbClr val="111111"/>
-          </a:solidFill>
-          <a:ln w="9525">
-            <a:solidFill>
-              <a:srgbClr val="111111"/>
-            </a:solidFill>
-            <a:prstDash val="solid"/>
-          </a:ln>
-        </p:spPr>
-      </p:sp>
-      <p:sp>
-        <p:nvSpPr>
-          <p:cNvPr id="16" name="矩形 15"/>
-          <p:cNvSpPr>
-            <a:spLocks noGrp="1"/>
-          </p:cNvSpPr>
-          <p:nvPr/>
-        </p:nvSpPr>
-        <p:spPr>
-          <a:xfrm>
-            <a:off x="8305800" y="1600200"/>
-            <a:ext cx="2952750" cy="266700"/>
-          </a:xfrm>
-          <a:prstGeom prst="rect">
-            <a:avLst/>
-          </a:prstGeom>
-          <a:noFill/>
-          <a:ln w="0">
-            <a:noFill/>
-            <a:prstDash val="solid"/>
-          </a:ln>
-        </p:spPr>
-        <p:txBody>
-          <a:bodyPr lIns="0" tIns="0" rIns="0" bIns="0" anchor="t"/>
-          <a:lstStyle/>
-          <a:p>
-            <a:pPr algn="l">
-              <a:defRPr sz="1500" b="1">
-                <a:solidFill>
-                  <a:srgbClr val="111111"/>
-                </a:solidFill>
-              </a:defRPr>
-            </a:pPr>
-            <a:r>
-              <a:rPr sz="1500" b="1">
-                <a:solidFill>
-                  <a:srgbClr val="111111"/>
-                </a:solidFill>
-              </a:rPr>
-              <a:t>后续工作</a:t>
-            </a:r>
-            <a:endParaRPr sz="1500" b="1">
-              <a:solidFill>
-                <a:srgbClr val="111111"/>
-              </a:solidFill>
-            </a:endParaRPr>
-          </a:p>
-        </p:txBody>
-      </p:sp>
-      <p:sp>
-        <p:nvSpPr>
-          <p:cNvPr id="17" name="矩形 16"/>
-          <p:cNvSpPr>
-            <a:spLocks noGrp="1"/>
-          </p:cNvSpPr>
-          <p:nvPr/>
-        </p:nvSpPr>
-        <p:spPr>
-          <a:xfrm>
-            <a:off x="8305800" y="1981200"/>
-            <a:ext cx="2933700" cy="1123950"/>
-          </a:xfrm>
-          <a:prstGeom prst="rect">
-            <a:avLst/>
-          </a:prstGeom>
-          <a:noFill/>
-          <a:ln w="0">
-            <a:noFill/>
-            <a:prstDash val="solid"/>
-          </a:ln>
-        </p:spPr>
-        <p:txBody>
-          <a:bodyPr lIns="0" tIns="0" rIns="0" bIns="0" anchor="t"/>
-          <a:lstStyle/>
-          <a:p>
-            <a:pPr algn="l">
+          <p:cNvPr id="28" name="矩形 27"/>
+          <p:cNvSpPr>
+            <a:spLocks noGrp="1"/>
+          </p:cNvSpPr>
+          <p:nvPr/>
+        </p:nvSpPr>
+        <p:spPr>
+          <a:xfrm>
+            <a:off x="1676400" y="5238750"/>
+            <a:ext cx="8267700" cy="266700"/>
+          </a:xfrm>
+          <a:prstGeom prst="rect">
+            <a:avLst/>
+          </a:prstGeom>
+          <a:noFill/>
+          <a:ln w="0">
+            <a:noFill/>
+            <a:prstDash val="solid"/>
+          </a:ln>
+        </p:spPr>
+        <p:txBody>
+          <a:bodyPr lIns="0" tIns="0" rIns="0" bIns="0" anchor="t"/>
+          <a:lstStyle/>
+          <a:p>
+            <a:pPr algn="ctr">
+              <a:defRPr sz="1800" b="1">
+                <a:solidFill>
+                  <a:srgbClr val="172033"/>
+                </a:solidFill>
+              </a:defRPr>
+            </a:pPr>
+            <a:r>
+              <a:rPr sz="1800" b="1">
+                <a:solidFill>
+                  <a:srgbClr val="172033"/>
+                </a:solidFill>
+              </a:rPr>
+              <a:t>最终代码以人工理解、真实运行和评测结果为准</a:t>
+            </a:r>
+            <a:endParaRPr sz="1800" b="1">
+              <a:solidFill>
+                <a:srgbClr val="172033"/>
+              </a:solidFill>
+            </a:endParaRPr>
+          </a:p>
+        </p:txBody>
+      </p:sp>
+      <p:sp>
+        <p:nvSpPr>
+          <p:cNvPr id="29" name="矩形 28"/>
+          <p:cNvSpPr>
+            <a:spLocks noGrp="1"/>
+          </p:cNvSpPr>
+          <p:nvPr/>
+        </p:nvSpPr>
+        <p:spPr>
+          <a:xfrm>
+            <a:off x="1676400" y="5562600"/>
+            <a:ext cx="8267700" cy="171450"/>
+          </a:xfrm>
+          <a:prstGeom prst="rect">
+            <a:avLst/>
+          </a:prstGeom>
+          <a:noFill/>
+          <a:ln w="0">
+            <a:noFill/>
+            <a:prstDash val="solid"/>
+          </a:ln>
+        </p:spPr>
+        <p:txBody>
+          <a:bodyPr lIns="0" tIns="0" rIns="0" bIns="0" anchor="t"/>
+          <a:lstStyle/>
+          <a:p>
+            <a:pPr algn="ctr">
               <a:defRPr sz="1125" b="0">
                 <a:solidFill>
                   <a:srgbClr val="4A4A4A"/>
@@ -17024,7 +17551,7 @@
                   <a:srgbClr val="4A4A4A"/>
                 </a:solidFill>
               </a:rPr>
-              <a:t>继续加固 pthread/futex、文件系统写回、pipe/进程性能、symlink/readlinkat 语义，并推进网络外部数据通路。</a:t>
+              <a:t>AI 输出不直接作为结论；所有关键修改经过构建、QEMU 运行、串口日志和 parser 结果验证。</a:t>
             </a:r>
             <a:endParaRPr sz="1125" b="0">
               <a:solidFill>
@@ -17036,134 +17563,7 @@
       </p:sp>
       <p:sp>
         <p:nvSpPr>
-          <p:cNvPr id="18" name="圆角矩形 17"/>
-          <p:cNvSpPr>
-            <a:spLocks noGrp="1"/>
-          </p:cNvSpPr>
-          <p:nvPr/>
-        </p:nvSpPr>
-        <p:spPr>
-          <a:xfrm>
-            <a:off x="1371600" y="4095750"/>
-            <a:ext cx="8915400" cy="800100"/>
-          </a:xfrm>
-          <a:prstGeom prst="roundRect">
-            <a:avLst>
-              <a:gd name="adj" fmla="val 4762"/>
-            </a:avLst>
-          </a:prstGeom>
-          <a:solidFill>
-            <a:srgbClr val="FFFFFF"/>
-          </a:solidFill>
-          <a:ln w="9525">
-            <a:solidFill>
-              <a:srgbClr val="D6D6D6"/>
-            </a:solidFill>
-            <a:prstDash val="solid"/>
-          </a:ln>
-        </p:spPr>
-      </p:sp>
-      <p:sp>
-        <p:nvSpPr>
-          <p:cNvPr id="19" name="矩形 18"/>
-          <p:cNvSpPr>
-            <a:spLocks noGrp="1"/>
-          </p:cNvSpPr>
-          <p:nvPr/>
-        </p:nvSpPr>
-        <p:spPr>
-          <a:xfrm>
-            <a:off x="1371600" y="4305300"/>
-            <a:ext cx="8915400" cy="285750"/>
-          </a:xfrm>
-          <a:prstGeom prst="rect">
-            <a:avLst/>
-          </a:prstGeom>
-          <a:noFill/>
-          <a:ln w="0">
-            <a:noFill/>
-            <a:prstDash val="solid"/>
-          </a:ln>
-        </p:spPr>
-        <p:txBody>
-          <a:bodyPr lIns="0" tIns="0" rIns="0" bIns="0" anchor="t"/>
-          <a:lstStyle/>
-          <a:p>
-            <a:pPr algn="ctr">
-              <a:defRPr sz="1875" b="1">
-                <a:solidFill>
-                  <a:srgbClr val="172033"/>
-                </a:solidFill>
-              </a:defRPr>
-            </a:pPr>
-            <a:r>
-              <a:rPr sz="1875" b="1">
-                <a:solidFill>
-                  <a:srgbClr val="172033"/>
-                </a:solidFill>
-              </a:rPr>
-              <a:t>wll_OS 已形成一条可复现的双架构内核评测路径</a:t>
-            </a:r>
-            <a:endParaRPr sz="1875" b="1">
-              <a:solidFill>
-                <a:srgbClr val="172033"/>
-              </a:solidFill>
-            </a:endParaRPr>
-          </a:p>
-        </p:txBody>
-      </p:sp>
-      <p:sp>
-        <p:nvSpPr>
-          <p:cNvPr id="20" name="矩形 19"/>
-          <p:cNvSpPr>
-            <a:spLocks noGrp="1"/>
-          </p:cNvSpPr>
-          <p:nvPr/>
-        </p:nvSpPr>
-        <p:spPr>
-          <a:xfrm>
-            <a:off x="1371600" y="4667250"/>
-            <a:ext cx="8915400" cy="209550"/>
-          </a:xfrm>
-          <a:prstGeom prst="rect">
-            <a:avLst/>
-          </a:prstGeom>
-          <a:noFill/>
-          <a:ln w="0">
-            <a:noFill/>
-            <a:prstDash val="solid"/>
-          </a:ln>
-        </p:spPr>
-        <p:txBody>
-          <a:bodyPr lIns="0" tIns="0" rIns="0" bIns="0" anchor="t"/>
-          <a:lstStyle/>
-          <a:p>
-            <a:pPr algn="ctr">
-              <a:defRPr sz="1275" b="0">
-                <a:solidFill>
-                  <a:srgbClr val="4A4A4A"/>
-                </a:solidFill>
-              </a:defRPr>
-            </a:pPr>
-            <a:r>
-              <a:rPr sz="1275" b="0">
-                <a:solidFill>
-                  <a:srgbClr val="4A4A4A"/>
-                </a:solidFill>
-              </a:rPr>
-              <a:t>构建产物、运行时镜像、串口日志、parser 结果与模块化实现相互对应</a:t>
-            </a:r>
-            <a:endParaRPr sz="1275" b="0">
-              <a:solidFill>
-                <a:srgbClr val="4A4A4A"/>
-              </a:solidFill>
-            </a:endParaRPr>
-          </a:p>
-        </p:txBody>
-      </p:sp>
-      <p:sp>
-        <p:nvSpPr>
-          <p:cNvPr id="21" name="矩形 20"/>
+          <p:cNvPr id="30" name="矩形 29"/>
           <p:cNvSpPr>
             <a:spLocks noGrp="1"/>
           </p:cNvSpPr>
@@ -17219,6 +17619,836 @@
 </file>
 
 <file path=ppt/slides/slide22.xml><?xml version="1.0" encoding="utf-8"?>
+<p:sld xmlns:a="http://schemas.openxmlformats.org/drawingml/2006/main" xmlns:r="http://schemas.openxmlformats.org/officeDocument/2006/relationships" xmlns:p="http://schemas.openxmlformats.org/presentationml/2006/main">
+  <p:cSld>
+    <p:spTree>
+      <p:nvGrpSpPr>
+        <p:cNvPr id="1" name=""/>
+        <p:cNvGrpSpPr/>
+        <p:nvPr/>
+      </p:nvGrpSpPr>
+      <p:grpSpPr/>
+      <p:sp>
+        <p:nvSpPr>
+          <p:cNvPr id="2" name="矩形 1"/>
+          <p:cNvSpPr>
+            <a:spLocks noGrp="1"/>
+          </p:cNvSpPr>
+          <p:nvPr/>
+        </p:nvSpPr>
+        <p:spPr>
+          <a:xfrm>
+            <a:off x="704850" y="419100"/>
+            <a:ext cx="8191500" cy="476250"/>
+          </a:xfrm>
+          <a:prstGeom prst="rect">
+            <a:avLst/>
+          </a:prstGeom>
+          <a:noFill/>
+          <a:ln w="0">
+            <a:noFill/>
+            <a:prstDash val="solid"/>
+          </a:ln>
+        </p:spPr>
+        <p:txBody>
+          <a:bodyPr lIns="0" tIns="0" rIns="0" bIns="0" anchor="t"/>
+          <a:lstStyle/>
+          <a:p>
+            <a:pPr algn="l">
+              <a:defRPr sz="2550" b="1">
+                <a:solidFill>
+                  <a:srgbClr val="111111"/>
+                </a:solidFill>
+              </a:defRPr>
+            </a:pPr>
+            <a:r>
+              <a:rPr sz="2550" b="1">
+                <a:solidFill>
+                  <a:srgbClr val="111111"/>
+                </a:solidFill>
+              </a:rPr>
+              <a:t>总结与计划</a:t>
+            </a:r>
+            <a:endParaRPr sz="2550" b="1">
+              <a:solidFill>
+                <a:srgbClr val="111111"/>
+              </a:solidFill>
+            </a:endParaRPr>
+          </a:p>
+        </p:txBody>
+      </p:sp>
+      <p:sp>
+        <p:nvSpPr>
+          <p:cNvPr id="3" name="矩形 2"/>
+          <p:cNvSpPr>
+            <a:spLocks noGrp="1"/>
+          </p:cNvSpPr>
+          <p:nvPr/>
+        </p:nvSpPr>
+        <p:spPr>
+          <a:xfrm>
+            <a:off x="704850" y="895350"/>
+            <a:ext cx="7810500" cy="228600"/>
+          </a:xfrm>
+          <a:prstGeom prst="rect">
+            <a:avLst/>
+          </a:prstGeom>
+          <a:noFill/>
+          <a:ln w="0">
+            <a:noFill/>
+            <a:prstDash val="solid"/>
+          </a:ln>
+        </p:spPr>
+        <p:txBody>
+          <a:bodyPr lIns="0" tIns="0" rIns="0" bIns="0" anchor="t"/>
+          <a:lstStyle/>
+          <a:p>
+            <a:pPr algn="l">
+              <a:defRPr sz="1050" b="1">
+                <a:solidFill>
+                  <a:srgbClr val="4A4A4A"/>
+                </a:solidFill>
+              </a:defRPr>
+            </a:pPr>
+            <a:r>
+              <a:rPr sz="1050" b="1">
+                <a:solidFill>
+                  <a:srgbClr val="4A4A4A"/>
+                </a:solidFill>
+              </a:rPr>
+              <a:t>当前阶段成果与下一步重点</a:t>
+            </a:r>
+            <a:endParaRPr sz="1050" b="1">
+              <a:solidFill>
+                <a:srgbClr val="4A4A4A"/>
+              </a:solidFill>
+            </a:endParaRPr>
+          </a:p>
+        </p:txBody>
+      </p:sp>
+      <p:sp>
+        <p:nvSpPr>
+          <p:cNvPr id="4" name="矩形 3"/>
+          <p:cNvSpPr>
+            <a:spLocks noGrp="1"/>
+          </p:cNvSpPr>
+          <p:nvPr/>
+        </p:nvSpPr>
+        <p:spPr>
+          <a:xfrm>
+            <a:off x="704850" y="1200150"/>
+            <a:ext cx="838200" cy="28575"/>
+          </a:xfrm>
+          <a:prstGeom prst="rect">
+            <a:avLst/>
+          </a:prstGeom>
+          <a:solidFill>
+            <a:srgbClr val="172033"/>
+          </a:solidFill>
+          <a:ln w="9525">
+            <a:solidFill>
+              <a:srgbClr val="172033"/>
+            </a:solidFill>
+            <a:prstDash val="solid"/>
+          </a:ln>
+        </p:spPr>
+      </p:sp>
+      <p:sp>
+        <p:nvSpPr>
+          <p:cNvPr id="5" name="矩形 4"/>
+          <p:cNvSpPr>
+            <a:spLocks noGrp="1"/>
+          </p:cNvSpPr>
+          <p:nvPr/>
+        </p:nvSpPr>
+        <p:spPr>
+          <a:xfrm>
+            <a:off x="10534650" y="457200"/>
+            <a:ext cx="914400" cy="228600"/>
+          </a:xfrm>
+          <a:prstGeom prst="rect">
+            <a:avLst/>
+          </a:prstGeom>
+          <a:noFill/>
+          <a:ln w="0">
+            <a:noFill/>
+            <a:prstDash val="solid"/>
+          </a:ln>
+        </p:spPr>
+        <p:txBody>
+          <a:bodyPr lIns="0" tIns="0" rIns="0" bIns="0" anchor="t"/>
+          <a:lstStyle/>
+          <a:p>
+            <a:pPr algn="r">
+              <a:defRPr sz="1125" b="1">
+                <a:solidFill>
+                  <a:srgbClr val="4A4A4A"/>
+                </a:solidFill>
+              </a:defRPr>
+            </a:pPr>
+            <a:r>
+              <a:rPr sz="1125" b="1">
+                <a:solidFill>
+                  <a:srgbClr val="4A4A4A"/>
+                </a:solidFill>
+              </a:rPr>
+              <a:t>wll_OS</a:t>
+            </a:r>
+            <a:endParaRPr sz="1125" b="1">
+              <a:solidFill>
+                <a:srgbClr val="4A4A4A"/>
+              </a:solidFill>
+            </a:endParaRPr>
+          </a:p>
+        </p:txBody>
+      </p:sp>
+      <p:sp>
+        <p:nvSpPr>
+          <p:cNvPr id="6" name="圆角矩形 5"/>
+          <p:cNvSpPr>
+            <a:spLocks noGrp="1"/>
+          </p:cNvSpPr>
+          <p:nvPr/>
+        </p:nvSpPr>
+        <p:spPr>
+          <a:xfrm>
+            <a:off x="819150" y="1428750"/>
+            <a:ext cx="3276600" cy="1809750"/>
+          </a:xfrm>
+          <a:prstGeom prst="roundRect">
+            <a:avLst>
+              <a:gd name="adj" fmla="val 4211"/>
+            </a:avLst>
+          </a:prstGeom>
+          <a:solidFill>
+            <a:srgbClr val="FFFFFF"/>
+          </a:solidFill>
+          <a:ln w="9525">
+            <a:solidFill>
+              <a:srgbClr val="D6D6D6"/>
+            </a:solidFill>
+            <a:prstDash val="solid"/>
+          </a:ln>
+        </p:spPr>
+      </p:sp>
+      <p:sp>
+        <p:nvSpPr>
+          <p:cNvPr id="7" name="矩形 6"/>
+          <p:cNvSpPr>
+            <a:spLocks noGrp="1"/>
+          </p:cNvSpPr>
+          <p:nvPr/>
+        </p:nvSpPr>
+        <p:spPr>
+          <a:xfrm>
+            <a:off x="819150" y="1428750"/>
+            <a:ext cx="47625" cy="1809750"/>
+          </a:xfrm>
+          <a:prstGeom prst="rect">
+            <a:avLst/>
+          </a:prstGeom>
+          <a:solidFill>
+            <a:srgbClr val="111111"/>
+          </a:solidFill>
+          <a:ln w="9525">
+            <a:solidFill>
+              <a:srgbClr val="111111"/>
+            </a:solidFill>
+            <a:prstDash val="solid"/>
+          </a:ln>
+        </p:spPr>
+      </p:sp>
+      <p:sp>
+        <p:nvSpPr>
+          <p:cNvPr id="8" name="矩形 7"/>
+          <p:cNvSpPr>
+            <a:spLocks noGrp="1"/>
+          </p:cNvSpPr>
+          <p:nvPr/>
+        </p:nvSpPr>
+        <p:spPr>
+          <a:xfrm>
+            <a:off x="1028700" y="1600200"/>
+            <a:ext cx="2952750" cy="266700"/>
+          </a:xfrm>
+          <a:prstGeom prst="rect">
+            <a:avLst/>
+          </a:prstGeom>
+          <a:noFill/>
+          <a:ln w="0">
+            <a:noFill/>
+            <a:prstDash val="solid"/>
+          </a:ln>
+        </p:spPr>
+        <p:txBody>
+          <a:bodyPr lIns="0" tIns="0" rIns="0" bIns="0" anchor="t"/>
+          <a:lstStyle/>
+          <a:p>
+            <a:pPr algn="l">
+              <a:defRPr sz="1500" b="1">
+                <a:solidFill>
+                  <a:srgbClr val="111111"/>
+                </a:solidFill>
+              </a:defRPr>
+            </a:pPr>
+            <a:r>
+              <a:rPr sz="1500" b="1">
+                <a:solidFill>
+                  <a:srgbClr val="111111"/>
+                </a:solidFill>
+              </a:rPr>
+              <a:t>阶段成果</a:t>
+            </a:r>
+            <a:endParaRPr sz="1500" b="1">
+              <a:solidFill>
+                <a:srgbClr val="111111"/>
+              </a:solidFill>
+            </a:endParaRPr>
+          </a:p>
+        </p:txBody>
+      </p:sp>
+      <p:sp>
+        <p:nvSpPr>
+          <p:cNvPr id="9" name="矩形 8"/>
+          <p:cNvSpPr>
+            <a:spLocks noGrp="1"/>
+          </p:cNvSpPr>
+          <p:nvPr/>
+        </p:nvSpPr>
+        <p:spPr>
+          <a:xfrm>
+            <a:off x="1028700" y="1981200"/>
+            <a:ext cx="2933700" cy="1123950"/>
+          </a:xfrm>
+          <a:prstGeom prst="rect">
+            <a:avLst/>
+          </a:prstGeom>
+          <a:noFill/>
+          <a:ln w="0">
+            <a:noFill/>
+            <a:prstDash val="solid"/>
+          </a:ln>
+        </p:spPr>
+        <p:txBody>
+          <a:bodyPr lIns="0" tIns="0" rIns="0" bIns="0" anchor="t"/>
+          <a:lstStyle/>
+          <a:p>
+            <a:pPr algn="l">
+              <a:defRPr sz="1125" b="0">
+                <a:solidFill>
+                  <a:srgbClr val="4A4A4A"/>
+                </a:solidFill>
+              </a:defRPr>
+            </a:pPr>
+            <a:r>
+              <a:rPr sz="1125" b="0">
+                <a:solidFill>
+                  <a:srgbClr val="4A4A4A"/>
+                </a:solidFill>
+              </a:rPr>
+              <a:t>完成双架构构建、运行时 ext4 脚本发现、核心 syscall 分层、VFS/FD、mmap/shm/futex/signal/socket 子集，以及多 suite harness 闭环。</a:t>
+            </a:r>
+            <a:endParaRPr sz="1125" b="0">
+              <a:solidFill>
+                <a:srgbClr val="4A4A4A"/>
+              </a:solidFill>
+            </a:endParaRPr>
+          </a:p>
+        </p:txBody>
+      </p:sp>
+      <p:sp>
+        <p:nvSpPr>
+          <p:cNvPr id="10" name="圆角矩形 9"/>
+          <p:cNvSpPr>
+            <a:spLocks noGrp="1"/>
+          </p:cNvSpPr>
+          <p:nvPr/>
+        </p:nvSpPr>
+        <p:spPr>
+          <a:xfrm>
+            <a:off x="4457700" y="1428750"/>
+            <a:ext cx="3276600" cy="1809750"/>
+          </a:xfrm>
+          <a:prstGeom prst="roundRect">
+            <a:avLst>
+              <a:gd name="adj" fmla="val 4211"/>
+            </a:avLst>
+          </a:prstGeom>
+          <a:solidFill>
+            <a:srgbClr val="FFFFFF"/>
+          </a:solidFill>
+          <a:ln w="9525">
+            <a:solidFill>
+              <a:srgbClr val="D6D6D6"/>
+            </a:solidFill>
+            <a:prstDash val="solid"/>
+          </a:ln>
+        </p:spPr>
+      </p:sp>
+      <p:sp>
+        <p:nvSpPr>
+          <p:cNvPr id="11" name="矩形 10"/>
+          <p:cNvSpPr>
+            <a:spLocks noGrp="1"/>
+          </p:cNvSpPr>
+          <p:nvPr/>
+        </p:nvSpPr>
+        <p:spPr>
+          <a:xfrm>
+            <a:off x="4457700" y="1428750"/>
+            <a:ext cx="47625" cy="1809750"/>
+          </a:xfrm>
+          <a:prstGeom prst="rect">
+            <a:avLst/>
+          </a:prstGeom>
+          <a:solidFill>
+            <a:srgbClr val="111111"/>
+          </a:solidFill>
+          <a:ln w="9525">
+            <a:solidFill>
+              <a:srgbClr val="111111"/>
+            </a:solidFill>
+            <a:prstDash val="solid"/>
+          </a:ln>
+        </p:spPr>
+      </p:sp>
+      <p:sp>
+        <p:nvSpPr>
+          <p:cNvPr id="12" name="矩形 11"/>
+          <p:cNvSpPr>
+            <a:spLocks noGrp="1"/>
+          </p:cNvSpPr>
+          <p:nvPr/>
+        </p:nvSpPr>
+        <p:spPr>
+          <a:xfrm>
+            <a:off x="4667250" y="1600200"/>
+            <a:ext cx="2952750" cy="266700"/>
+          </a:xfrm>
+          <a:prstGeom prst="rect">
+            <a:avLst/>
+          </a:prstGeom>
+          <a:noFill/>
+          <a:ln w="0">
+            <a:noFill/>
+            <a:prstDash val="solid"/>
+          </a:ln>
+        </p:spPr>
+        <p:txBody>
+          <a:bodyPr lIns="0" tIns="0" rIns="0" bIns="0" anchor="t"/>
+          <a:lstStyle/>
+          <a:p>
+            <a:pPr algn="l">
+              <a:defRPr sz="1500" b="1">
+                <a:solidFill>
+                  <a:srgbClr val="111111"/>
+                </a:solidFill>
+              </a:defRPr>
+            </a:pPr>
+            <a:r>
+              <a:rPr sz="1500" b="1">
+                <a:solidFill>
+                  <a:srgbClr val="111111"/>
+                </a:solidFill>
+              </a:rPr>
+              <a:t>技术特点</a:t>
+            </a:r>
+            <a:endParaRPr sz="1500" b="1">
+              <a:solidFill>
+                <a:srgbClr val="111111"/>
+              </a:solidFill>
+            </a:endParaRPr>
+          </a:p>
+        </p:txBody>
+      </p:sp>
+      <p:sp>
+        <p:nvSpPr>
+          <p:cNvPr id="13" name="矩形 12"/>
+          <p:cNvSpPr>
+            <a:spLocks noGrp="1"/>
+          </p:cNvSpPr>
+          <p:nvPr/>
+        </p:nvSpPr>
+        <p:spPr>
+          <a:xfrm>
+            <a:off x="4667250" y="1981200"/>
+            <a:ext cx="2933700" cy="1123950"/>
+          </a:xfrm>
+          <a:prstGeom prst="rect">
+            <a:avLst/>
+          </a:prstGeom>
+          <a:noFill/>
+          <a:ln w="0">
+            <a:noFill/>
+            <a:prstDash val="solid"/>
+          </a:ln>
+        </p:spPr>
+        <p:txBody>
+          <a:bodyPr lIns="0" tIns="0" rIns="0" bIns="0" anchor="t"/>
+          <a:lstStyle/>
+          <a:p>
+            <a:pPr algn="l">
+              <a:defRPr sz="1125" b="0">
+                <a:solidFill>
+                  <a:srgbClr val="4A4A4A"/>
+                </a:solidFill>
+              </a:defRPr>
+            </a:pPr>
+            <a:r>
+              <a:rPr sz="1125" b="0">
+                <a:solidFill>
+                  <a:srgbClr val="4A4A4A"/>
+                </a:solidFill>
+              </a:rPr>
+              <a:t>Rust 内核、分层 ABI、真实等待队列、渐进式 LTP、以日志与 parser 为准的验证方式，便于持续定位评测差距。</a:t>
+            </a:r>
+            <a:endParaRPr sz="1125" b="0">
+              <a:solidFill>
+                <a:srgbClr val="4A4A4A"/>
+              </a:solidFill>
+            </a:endParaRPr>
+          </a:p>
+        </p:txBody>
+      </p:sp>
+      <p:sp>
+        <p:nvSpPr>
+          <p:cNvPr id="14" name="圆角矩形 13"/>
+          <p:cNvSpPr>
+            <a:spLocks noGrp="1"/>
+          </p:cNvSpPr>
+          <p:nvPr/>
+        </p:nvSpPr>
+        <p:spPr>
+          <a:xfrm>
+            <a:off x="8096250" y="1428750"/>
+            <a:ext cx="3276600" cy="1809750"/>
+          </a:xfrm>
+          <a:prstGeom prst="roundRect">
+            <a:avLst>
+              <a:gd name="adj" fmla="val 4211"/>
+            </a:avLst>
+          </a:prstGeom>
+          <a:solidFill>
+            <a:srgbClr val="FFFFFF"/>
+          </a:solidFill>
+          <a:ln w="9525">
+            <a:solidFill>
+              <a:srgbClr val="D6D6D6"/>
+            </a:solidFill>
+            <a:prstDash val="solid"/>
+          </a:ln>
+        </p:spPr>
+      </p:sp>
+      <p:sp>
+        <p:nvSpPr>
+          <p:cNvPr id="15" name="矩形 14"/>
+          <p:cNvSpPr>
+            <a:spLocks noGrp="1"/>
+          </p:cNvSpPr>
+          <p:nvPr/>
+        </p:nvSpPr>
+        <p:spPr>
+          <a:xfrm>
+            <a:off x="8096250" y="1428750"/>
+            <a:ext cx="47625" cy="1809750"/>
+          </a:xfrm>
+          <a:prstGeom prst="rect">
+            <a:avLst/>
+          </a:prstGeom>
+          <a:solidFill>
+            <a:srgbClr val="111111"/>
+          </a:solidFill>
+          <a:ln w="9525">
+            <a:solidFill>
+              <a:srgbClr val="111111"/>
+            </a:solidFill>
+            <a:prstDash val="solid"/>
+          </a:ln>
+        </p:spPr>
+      </p:sp>
+      <p:sp>
+        <p:nvSpPr>
+          <p:cNvPr id="16" name="矩形 15"/>
+          <p:cNvSpPr>
+            <a:spLocks noGrp="1"/>
+          </p:cNvSpPr>
+          <p:nvPr/>
+        </p:nvSpPr>
+        <p:spPr>
+          <a:xfrm>
+            <a:off x="8305800" y="1600200"/>
+            <a:ext cx="2952750" cy="266700"/>
+          </a:xfrm>
+          <a:prstGeom prst="rect">
+            <a:avLst/>
+          </a:prstGeom>
+          <a:noFill/>
+          <a:ln w="0">
+            <a:noFill/>
+            <a:prstDash val="solid"/>
+          </a:ln>
+        </p:spPr>
+        <p:txBody>
+          <a:bodyPr lIns="0" tIns="0" rIns="0" bIns="0" anchor="t"/>
+          <a:lstStyle/>
+          <a:p>
+            <a:pPr algn="l">
+              <a:defRPr sz="1500" b="1">
+                <a:solidFill>
+                  <a:srgbClr val="111111"/>
+                </a:solidFill>
+              </a:defRPr>
+            </a:pPr>
+            <a:r>
+              <a:rPr sz="1500" b="1">
+                <a:solidFill>
+                  <a:srgbClr val="111111"/>
+                </a:solidFill>
+              </a:rPr>
+              <a:t>后续工作</a:t>
+            </a:r>
+            <a:endParaRPr sz="1500" b="1">
+              <a:solidFill>
+                <a:srgbClr val="111111"/>
+              </a:solidFill>
+            </a:endParaRPr>
+          </a:p>
+        </p:txBody>
+      </p:sp>
+      <p:sp>
+        <p:nvSpPr>
+          <p:cNvPr id="17" name="矩形 16"/>
+          <p:cNvSpPr>
+            <a:spLocks noGrp="1"/>
+          </p:cNvSpPr>
+          <p:nvPr/>
+        </p:nvSpPr>
+        <p:spPr>
+          <a:xfrm>
+            <a:off x="8305800" y="1981200"/>
+            <a:ext cx="2933700" cy="1123950"/>
+          </a:xfrm>
+          <a:prstGeom prst="rect">
+            <a:avLst/>
+          </a:prstGeom>
+          <a:noFill/>
+          <a:ln w="0">
+            <a:noFill/>
+            <a:prstDash val="solid"/>
+          </a:ln>
+        </p:spPr>
+        <p:txBody>
+          <a:bodyPr lIns="0" tIns="0" rIns="0" bIns="0" anchor="t"/>
+          <a:lstStyle/>
+          <a:p>
+            <a:pPr algn="l">
+              <a:defRPr sz="1125" b="0">
+                <a:solidFill>
+                  <a:srgbClr val="4A4A4A"/>
+                </a:solidFill>
+              </a:defRPr>
+            </a:pPr>
+            <a:r>
+              <a:rPr sz="1125" b="0">
+                <a:solidFill>
+                  <a:srgbClr val="4A4A4A"/>
+                </a:solidFill>
+              </a:rPr>
+              <a:t>继续加固 pthread/futex、文件系统写回、pipe/进程性能、symlink/readlinkat 语义，并推进网络外部数据通路。</a:t>
+            </a:r>
+            <a:endParaRPr sz="1125" b="0">
+              <a:solidFill>
+                <a:srgbClr val="4A4A4A"/>
+              </a:solidFill>
+            </a:endParaRPr>
+          </a:p>
+        </p:txBody>
+      </p:sp>
+      <p:sp>
+        <p:nvSpPr>
+          <p:cNvPr id="18" name="圆角矩形 17"/>
+          <p:cNvSpPr>
+            <a:spLocks noGrp="1"/>
+          </p:cNvSpPr>
+          <p:nvPr/>
+        </p:nvSpPr>
+        <p:spPr>
+          <a:xfrm>
+            <a:off x="1371600" y="4095750"/>
+            <a:ext cx="8915400" cy="800100"/>
+          </a:xfrm>
+          <a:prstGeom prst="roundRect">
+            <a:avLst>
+              <a:gd name="adj" fmla="val 4762"/>
+            </a:avLst>
+          </a:prstGeom>
+          <a:solidFill>
+            <a:srgbClr val="FFFFFF"/>
+          </a:solidFill>
+          <a:ln w="9525">
+            <a:solidFill>
+              <a:srgbClr val="D6D6D6"/>
+            </a:solidFill>
+            <a:prstDash val="solid"/>
+          </a:ln>
+        </p:spPr>
+      </p:sp>
+      <p:sp>
+        <p:nvSpPr>
+          <p:cNvPr id="19" name="矩形 18"/>
+          <p:cNvSpPr>
+            <a:spLocks noGrp="1"/>
+          </p:cNvSpPr>
+          <p:nvPr/>
+        </p:nvSpPr>
+        <p:spPr>
+          <a:xfrm>
+            <a:off x="1371600" y="4305300"/>
+            <a:ext cx="8915400" cy="285750"/>
+          </a:xfrm>
+          <a:prstGeom prst="rect">
+            <a:avLst/>
+          </a:prstGeom>
+          <a:noFill/>
+          <a:ln w="0">
+            <a:noFill/>
+            <a:prstDash val="solid"/>
+          </a:ln>
+        </p:spPr>
+        <p:txBody>
+          <a:bodyPr lIns="0" tIns="0" rIns="0" bIns="0" anchor="t"/>
+          <a:lstStyle/>
+          <a:p>
+            <a:pPr algn="ctr">
+              <a:defRPr sz="1875" b="1">
+                <a:solidFill>
+                  <a:srgbClr val="172033"/>
+                </a:solidFill>
+              </a:defRPr>
+            </a:pPr>
+            <a:r>
+              <a:rPr sz="1875" b="1">
+                <a:solidFill>
+                  <a:srgbClr val="172033"/>
+                </a:solidFill>
+              </a:rPr>
+              <a:t>wll_OS 已形成一条可复现的双架构内核评测路径</a:t>
+            </a:r>
+            <a:endParaRPr sz="1875" b="1">
+              <a:solidFill>
+                <a:srgbClr val="172033"/>
+              </a:solidFill>
+            </a:endParaRPr>
+          </a:p>
+        </p:txBody>
+      </p:sp>
+      <p:sp>
+        <p:nvSpPr>
+          <p:cNvPr id="20" name="矩形 19"/>
+          <p:cNvSpPr>
+            <a:spLocks noGrp="1"/>
+          </p:cNvSpPr>
+          <p:nvPr/>
+        </p:nvSpPr>
+        <p:spPr>
+          <a:xfrm>
+            <a:off x="1371600" y="4667250"/>
+            <a:ext cx="8915400" cy="209550"/>
+          </a:xfrm>
+          <a:prstGeom prst="rect">
+            <a:avLst/>
+          </a:prstGeom>
+          <a:noFill/>
+          <a:ln w="0">
+            <a:noFill/>
+            <a:prstDash val="solid"/>
+          </a:ln>
+        </p:spPr>
+        <p:txBody>
+          <a:bodyPr lIns="0" tIns="0" rIns="0" bIns="0" anchor="t"/>
+          <a:lstStyle/>
+          <a:p>
+            <a:pPr algn="ctr">
+              <a:defRPr sz="1275" b="0">
+                <a:solidFill>
+                  <a:srgbClr val="4A4A4A"/>
+                </a:solidFill>
+              </a:defRPr>
+            </a:pPr>
+            <a:r>
+              <a:rPr sz="1275" b="0">
+                <a:solidFill>
+                  <a:srgbClr val="4A4A4A"/>
+                </a:solidFill>
+              </a:rPr>
+              <a:t>构建产物、运行时镜像、串口日志、parser 结果与模块化实现相互对应</a:t>
+            </a:r>
+            <a:endParaRPr sz="1275" b="0">
+              <a:solidFill>
+                <a:srgbClr val="4A4A4A"/>
+              </a:solidFill>
+            </a:endParaRPr>
+          </a:p>
+        </p:txBody>
+      </p:sp>
+      <p:sp>
+        <p:nvSpPr>
+          <p:cNvPr id="21" name="矩形 20"/>
+          <p:cNvSpPr>
+            <a:spLocks noGrp="1"/>
+          </p:cNvSpPr>
+          <p:nvPr/>
+        </p:nvSpPr>
+        <p:spPr>
+          <a:xfrm>
+            <a:off x="10839450" y="6191250"/>
+            <a:ext cx="590550" cy="228600"/>
+          </a:xfrm>
+          <a:prstGeom prst="rect">
+            <a:avLst/>
+          </a:prstGeom>
+          <a:noFill/>
+          <a:ln w="0">
+            <a:noFill/>
+            <a:prstDash val="solid"/>
+          </a:ln>
+        </p:spPr>
+        <p:txBody>
+          <a:bodyPr lIns="0" tIns="0" rIns="0" bIns="0" anchor="t"/>
+          <a:lstStyle/>
+          <a:p>
+            <a:pPr algn="r">
+              <a:defRPr sz="975" b="0">
+                <a:solidFill>
+                  <a:srgbClr val="4A4A4A"/>
+                </a:solidFill>
+              </a:defRPr>
+            </a:pPr>
+            <a:r>
+              <a:rPr sz="975" b="0">
+                <a:solidFill>
+                  <a:srgbClr val="4A4A4A"/>
+                </a:solidFill>
+              </a:rPr>
+              <a:t>22</a:t>
+            </a:r>
+            <a:endParaRPr sz="975" b="0">
+              <a:solidFill>
+                <a:srgbClr val="4A4A4A"/>
+              </a:solidFill>
+            </a:endParaRPr>
+          </a:p>
+        </p:txBody>
+      </p:sp>
+    </p:spTree>
+  </p:cSld>
+  <p:clrMapOvr>
+    <a:masterClrMapping/>
+  </p:clrMapOvr>
+</p:sld>
+</file>
+
+<file path=ppt/slides/slide23.xml><?xml version="1.0" encoding="utf-8"?>
 <p:sld xmlns:a="http://schemas.openxmlformats.org/drawingml/2006/main" xmlns:r="http://schemas.openxmlformats.org/officeDocument/2006/relationships" xmlns:p="http://schemas.openxmlformats.org/presentationml/2006/main">
   <p:cSld>
     <p:bg>

</xml_diff>